<commit_message>
Lowered camera 1 unit, added better floors
</commit_message>
<xml_diff>
--- a/Documents/licart.pptx
+++ b/Documents/licart.pptx
@@ -248,7 +248,7 @@
           <a:p>
             <a:fld id="{89118853-9688-4D3D-BC78-5C03EB5BD2E8}" type="datetimeFigureOut">
               <a:rPr lang="en-US" smtClean="0"/>
-              <a:t>6/4/2025</a:t>
+              <a:t>7/14/2025</a:t>
             </a:fld>
             <a:endParaRPr lang="en-US"/>
           </a:p>
@@ -418,7 +418,7 @@
           <a:p>
             <a:fld id="{89118853-9688-4D3D-BC78-5C03EB5BD2E8}" type="datetimeFigureOut">
               <a:rPr lang="en-US" smtClean="0"/>
-              <a:t>6/4/2025</a:t>
+              <a:t>7/14/2025</a:t>
             </a:fld>
             <a:endParaRPr lang="en-US"/>
           </a:p>
@@ -598,7 +598,7 @@
           <a:p>
             <a:fld id="{89118853-9688-4D3D-BC78-5C03EB5BD2E8}" type="datetimeFigureOut">
               <a:rPr lang="en-US" smtClean="0"/>
-              <a:t>6/4/2025</a:t>
+              <a:t>7/14/2025</a:t>
             </a:fld>
             <a:endParaRPr lang="en-US"/>
           </a:p>
@@ -768,7 +768,7 @@
           <a:p>
             <a:fld id="{89118853-9688-4D3D-BC78-5C03EB5BD2E8}" type="datetimeFigureOut">
               <a:rPr lang="en-US" smtClean="0"/>
-              <a:t>6/4/2025</a:t>
+              <a:t>7/14/2025</a:t>
             </a:fld>
             <a:endParaRPr lang="en-US"/>
           </a:p>
@@ -1014,7 +1014,7 @@
           <a:p>
             <a:fld id="{89118853-9688-4D3D-BC78-5C03EB5BD2E8}" type="datetimeFigureOut">
               <a:rPr lang="en-US" smtClean="0"/>
-              <a:t>6/4/2025</a:t>
+              <a:t>7/14/2025</a:t>
             </a:fld>
             <a:endParaRPr lang="en-US"/>
           </a:p>
@@ -1246,7 +1246,7 @@
           <a:p>
             <a:fld id="{89118853-9688-4D3D-BC78-5C03EB5BD2E8}" type="datetimeFigureOut">
               <a:rPr lang="en-US" smtClean="0"/>
-              <a:t>6/4/2025</a:t>
+              <a:t>7/14/2025</a:t>
             </a:fld>
             <a:endParaRPr lang="en-US"/>
           </a:p>
@@ -1613,7 +1613,7 @@
           <a:p>
             <a:fld id="{89118853-9688-4D3D-BC78-5C03EB5BD2E8}" type="datetimeFigureOut">
               <a:rPr lang="en-US" smtClean="0"/>
-              <a:t>6/4/2025</a:t>
+              <a:t>7/14/2025</a:t>
             </a:fld>
             <a:endParaRPr lang="en-US"/>
           </a:p>
@@ -1731,7 +1731,7 @@
           <a:p>
             <a:fld id="{89118853-9688-4D3D-BC78-5C03EB5BD2E8}" type="datetimeFigureOut">
               <a:rPr lang="en-US" smtClean="0"/>
-              <a:t>6/4/2025</a:t>
+              <a:t>7/14/2025</a:t>
             </a:fld>
             <a:endParaRPr lang="en-US"/>
           </a:p>
@@ -1826,7 +1826,7 @@
           <a:p>
             <a:fld id="{89118853-9688-4D3D-BC78-5C03EB5BD2E8}" type="datetimeFigureOut">
               <a:rPr lang="en-US" smtClean="0"/>
-              <a:t>6/4/2025</a:t>
+              <a:t>7/14/2025</a:t>
             </a:fld>
             <a:endParaRPr lang="en-US"/>
           </a:p>
@@ -2103,7 +2103,7 @@
           <a:p>
             <a:fld id="{89118853-9688-4D3D-BC78-5C03EB5BD2E8}" type="datetimeFigureOut">
               <a:rPr lang="en-US" smtClean="0"/>
-              <a:t>6/4/2025</a:t>
+              <a:t>7/14/2025</a:t>
             </a:fld>
             <a:endParaRPr lang="en-US"/>
           </a:p>
@@ -2360,7 +2360,7 @@
           <a:p>
             <a:fld id="{89118853-9688-4D3D-BC78-5C03EB5BD2E8}" type="datetimeFigureOut">
               <a:rPr lang="en-US" smtClean="0"/>
-              <a:t>6/4/2025</a:t>
+              <a:t>7/14/2025</a:t>
             </a:fld>
             <a:endParaRPr lang="en-US"/>
           </a:p>
@@ -2573,7 +2573,7 @@
           <a:p>
             <a:fld id="{89118853-9688-4D3D-BC78-5C03EB5BD2E8}" type="datetimeFigureOut">
               <a:rPr lang="en-US" smtClean="0"/>
-              <a:t>6/4/2025</a:t>
+              <a:t>7/14/2025</a:t>
             </a:fld>
             <a:endParaRPr lang="en-US"/>
           </a:p>
@@ -23634,10 +23634,10 @@
           </p:nvGrpSpPr>
           <p:grpSpPr>
             <a:xfrm>
-              <a:off x="13198787" y="6704013"/>
-              <a:ext cx="1729188" cy="312692"/>
-              <a:chOff x="8818517" y="5128260"/>
-              <a:chExt cx="1920919" cy="563880"/>
+              <a:off x="13198787" y="6704009"/>
+              <a:ext cx="1729188" cy="397973"/>
+              <a:chOff x="8818517" y="5128269"/>
+              <a:chExt cx="1920919" cy="717670"/>
             </a:xfrm>
             <a:solidFill>
               <a:schemeClr val="bg1">
@@ -23659,8 +23659,8 @@
             </p:nvSpPr>
             <p:spPr>
               <a:xfrm>
-                <a:off x="8818517" y="5128260"/>
-                <a:ext cx="1920919" cy="563880"/>
+                <a:off x="8818517" y="5128269"/>
+                <a:ext cx="1920919" cy="717668"/>
               </a:xfrm>
               <a:prstGeom prst="roundRect">
                 <a:avLst/>
@@ -23709,8 +23709,8 @@
             </p:nvSpPr>
             <p:spPr>
               <a:xfrm>
-                <a:off x="8982075" y="5128260"/>
-                <a:ext cx="1757360" cy="563880"/>
+                <a:off x="8982075" y="5128271"/>
+                <a:ext cx="1757360" cy="717668"/>
               </a:xfrm>
               <a:prstGeom prst="rect">
                 <a:avLst/>
@@ -23741,7 +23741,7 @@
               <a:lstStyle/>
               <a:p>
                 <a:pPr algn="ctr"/>
-                <a:endParaRPr lang="en-US"/>
+                <a:endParaRPr lang="en-US" dirty="0"/>
               </a:p>
             </p:txBody>
           </p:sp>
@@ -23760,10 +23760,10 @@
           </p:nvGrpSpPr>
           <p:grpSpPr>
             <a:xfrm>
-              <a:off x="13198787" y="7604125"/>
-              <a:ext cx="1718140" cy="742950"/>
+              <a:off x="13198787" y="7604118"/>
+              <a:ext cx="1718140" cy="792748"/>
               <a:chOff x="8818517" y="5128260"/>
-              <a:chExt cx="1920919" cy="563880"/>
+              <a:chExt cx="1920919" cy="601676"/>
             </a:xfrm>
             <a:solidFill>
               <a:schemeClr val="bg1">
@@ -23786,7 +23786,7 @@
             <p:spPr>
               <a:xfrm>
                 <a:off x="8818517" y="5128260"/>
-                <a:ext cx="1920919" cy="563880"/>
+                <a:ext cx="1920919" cy="601675"/>
               </a:xfrm>
               <a:prstGeom prst="roundRect">
                 <a:avLst/>
@@ -23836,7 +23836,7 @@
             <p:spPr>
               <a:xfrm>
                 <a:off x="8982075" y="5128260"/>
-                <a:ext cx="1757360" cy="563880"/>
+                <a:ext cx="1757360" cy="601676"/>
               </a:xfrm>
               <a:prstGeom prst="rect">
                 <a:avLst/>
@@ -23886,10 +23886,10 @@
           </p:nvGrpSpPr>
           <p:grpSpPr>
             <a:xfrm>
-              <a:off x="13198787" y="8907462"/>
-              <a:ext cx="1729187" cy="472273"/>
+              <a:off x="13198787" y="8907459"/>
+              <a:ext cx="1729187" cy="512272"/>
               <a:chOff x="8818517" y="5128260"/>
-              <a:chExt cx="1920919" cy="563880"/>
+              <a:chExt cx="1920919" cy="611638"/>
             </a:xfrm>
             <a:solidFill>
               <a:schemeClr val="bg1">
@@ -23912,7 +23912,7 @@
             <p:spPr>
               <a:xfrm>
                 <a:off x="8818517" y="5128260"/>
-                <a:ext cx="1920919" cy="563880"/>
+                <a:ext cx="1920919" cy="611638"/>
               </a:xfrm>
               <a:prstGeom prst="roundRect">
                 <a:avLst/>
@@ -23962,7 +23962,7 @@
             <p:spPr>
               <a:xfrm>
                 <a:off x="8982075" y="5128260"/>
-                <a:ext cx="1757360" cy="563880"/>
+                <a:ext cx="1757360" cy="611638"/>
               </a:xfrm>
               <a:prstGeom prst="rect">
                 <a:avLst/>
@@ -24012,10 +24012,10 @@
           </p:nvGrpSpPr>
           <p:grpSpPr>
             <a:xfrm>
-              <a:off x="13403056" y="6784975"/>
-              <a:ext cx="1528093" cy="155268"/>
+              <a:off x="13403056" y="6784976"/>
+              <a:ext cx="1528093" cy="281464"/>
               <a:chOff x="8818517" y="5128260"/>
-              <a:chExt cx="1920919" cy="563880"/>
+              <a:chExt cx="1920919" cy="1022180"/>
             </a:xfrm>
             <a:solidFill>
               <a:schemeClr val="bg1">
@@ -24038,7 +24038,7 @@
             <p:spPr>
               <a:xfrm>
                 <a:off x="8818517" y="5128260"/>
-                <a:ext cx="1920919" cy="563880"/>
+                <a:ext cx="1920919" cy="1022180"/>
               </a:xfrm>
               <a:prstGeom prst="roundRect">
                 <a:avLst/>
@@ -24087,8 +24087,8 @@
             </p:nvSpPr>
             <p:spPr>
               <a:xfrm>
-                <a:off x="8982075" y="5128260"/>
-                <a:ext cx="1757360" cy="563880"/>
+                <a:off x="8982076" y="5128260"/>
+                <a:ext cx="1757360" cy="1022180"/>
               </a:xfrm>
               <a:prstGeom prst="rect">
                 <a:avLst/>
@@ -24138,10 +24138,10 @@
           </p:nvGrpSpPr>
           <p:grpSpPr>
             <a:xfrm>
-              <a:off x="13436458" y="7755327"/>
-              <a:ext cx="1480468" cy="446972"/>
-              <a:chOff x="8818517" y="5128260"/>
-              <a:chExt cx="1920919" cy="563880"/>
+              <a:off x="13436458" y="7755323"/>
+              <a:ext cx="1480468" cy="572209"/>
+              <a:chOff x="8818517" y="5128259"/>
+              <a:chExt cx="1920919" cy="721874"/>
             </a:xfrm>
             <a:solidFill>
               <a:schemeClr val="bg1">
@@ -24163,8 +24163,8 @@
             </p:nvSpPr>
             <p:spPr>
               <a:xfrm>
-                <a:off x="8818517" y="5128260"/>
-                <a:ext cx="1920919" cy="563880"/>
+                <a:off x="8818517" y="5128259"/>
+                <a:ext cx="1920919" cy="721874"/>
               </a:xfrm>
               <a:prstGeom prst="roundRect">
                 <a:avLst/>
@@ -24213,8 +24213,8 @@
             </p:nvSpPr>
             <p:spPr>
               <a:xfrm>
-                <a:off x="8982075" y="5128260"/>
-                <a:ext cx="1757360" cy="563880"/>
+                <a:off x="8982073" y="5128259"/>
+                <a:ext cx="1757362" cy="721874"/>
               </a:xfrm>
               <a:prstGeom prst="rect">
                 <a:avLst/>
@@ -24265,9 +24265,9 @@
           <p:grpSpPr>
             <a:xfrm>
               <a:off x="13516561" y="9003155"/>
-              <a:ext cx="1413793" cy="299235"/>
+              <a:ext cx="1413793" cy="379472"/>
               <a:chOff x="8818517" y="5128260"/>
-              <a:chExt cx="1920919" cy="563880"/>
+              <a:chExt cx="1920919" cy="715079"/>
             </a:xfrm>
             <a:solidFill>
               <a:schemeClr val="bg1">
@@ -24290,7 +24290,7 @@
             <p:spPr>
               <a:xfrm>
                 <a:off x="8818517" y="5128260"/>
-                <a:ext cx="1920919" cy="563880"/>
+                <a:ext cx="1920919" cy="715079"/>
               </a:xfrm>
               <a:prstGeom prst="roundRect">
                 <a:avLst/>
@@ -24339,8 +24339,8 @@
             </p:nvSpPr>
             <p:spPr>
               <a:xfrm>
-                <a:off x="8982075" y="5128260"/>
-                <a:ext cx="1757360" cy="563880"/>
+                <a:off x="8982074" y="5128260"/>
+                <a:ext cx="1757360" cy="715079"/>
               </a:xfrm>
               <a:prstGeom prst="rect">
                 <a:avLst/>

</xml_diff>

<commit_message>
Made projectiles "throw" with bullet logic
Player can now throw objects. Uses the bullet logic from shooting a gun.
</commit_message>
<xml_diff>
--- a/Documents/licart.pptx
+++ b/Documents/licart.pptx
@@ -9618,837 +9618,816 @@
           </p:txBody>
         </p:sp>
       </p:grpSp>
-      <p:grpSp>
-        <p:nvGrpSpPr>
-          <p:cNvPr id="50" name="Group 49">
+      <p:sp>
+        <p:nvSpPr>
+          <p:cNvPr id="35" name="Rectangle 34">
             <a:extLst>
               <a:ext uri="{FF2B5EF4-FFF2-40B4-BE49-F238E27FC236}">
-                <a16:creationId xmlns:a16="http://schemas.microsoft.com/office/drawing/2014/main" id="{B2F96EEE-8C8D-46F9-9761-4B4D6482CFCD}"/>
+                <a16:creationId xmlns:a16="http://schemas.microsoft.com/office/drawing/2014/main" id="{46416E86-EA31-2E27-39B9-BA0A3E552424}"/>
               </a:ext>
             </a:extLst>
           </p:cNvPr>
-          <p:cNvGrpSpPr/>
+          <p:cNvSpPr/>
           <p:nvPr/>
-        </p:nvGrpSpPr>
-        <p:grpSpPr>
-          <a:xfrm>
-            <a:off x="3400" y="9288124"/>
-            <a:ext cx="18294798" cy="8999876"/>
-            <a:chOff x="0" y="9383107"/>
-            <a:chExt cx="18294798" cy="8999876"/>
+        </p:nvSpPr>
+        <p:spPr>
+          <a:xfrm rot="10800000">
+            <a:off x="6799" y="12772760"/>
+            <a:ext cx="18288000" cy="5515240"/>
           </a:xfrm>
-        </p:grpSpPr>
-        <p:sp>
-          <p:nvSpPr>
-            <p:cNvPr id="35" name="Rectangle 34">
-              <a:extLst>
-                <a:ext uri="{FF2B5EF4-FFF2-40B4-BE49-F238E27FC236}">
-                  <a16:creationId xmlns:a16="http://schemas.microsoft.com/office/drawing/2014/main" id="{46416E86-EA31-2E27-39B9-BA0A3E552424}"/>
-                </a:ext>
-              </a:extLst>
-            </p:cNvPr>
-            <p:cNvSpPr/>
-            <p:nvPr/>
-          </p:nvSpPr>
-          <p:spPr>
-            <a:xfrm rot="10800000">
-              <a:off x="3399" y="9383107"/>
-              <a:ext cx="18288000" cy="8999876"/>
-            </a:xfrm>
-            <a:prstGeom prst="rect">
-              <a:avLst/>
-            </a:prstGeom>
-            <a:solidFill>
-              <a:schemeClr val="bg1">
-                <a:lumMod val="75000"/>
-              </a:schemeClr>
-            </a:solidFill>
-            <a:ln>
-              <a:noFill/>
-            </a:ln>
-          </p:spPr>
-          <p:style>
-            <a:lnRef idx="2">
-              <a:schemeClr val="accent1">
-                <a:shade val="15000"/>
-              </a:schemeClr>
-            </a:lnRef>
-            <a:fillRef idx="1">
-              <a:schemeClr val="accent1"/>
-            </a:fillRef>
-            <a:effectRef idx="0">
-              <a:schemeClr val="accent1"/>
-            </a:effectRef>
-            <a:fontRef idx="minor">
-              <a:schemeClr val="lt1"/>
-            </a:fontRef>
-          </p:style>
-          <p:txBody>
-            <a:bodyPr rtlCol="0" anchor="ctr"/>
-            <a:lstStyle/>
-            <a:p>
-              <a:pPr algn="ctr"/>
-              <a:endParaRPr lang="en-US"/>
-            </a:p>
-          </p:txBody>
-        </p:sp>
-        <p:sp>
-          <p:nvSpPr>
-            <p:cNvPr id="36" name="Rectangle 35">
-              <a:extLst>
-                <a:ext uri="{FF2B5EF4-FFF2-40B4-BE49-F238E27FC236}">
-                  <a16:creationId xmlns:a16="http://schemas.microsoft.com/office/drawing/2014/main" id="{847A4DFB-999D-7EFF-B8C3-3F0D00759642}"/>
-                </a:ext>
-              </a:extLst>
-            </p:cNvPr>
-            <p:cNvSpPr/>
-            <p:nvPr/>
-          </p:nvSpPr>
-          <p:spPr>
-            <a:xfrm rot="10800000">
-              <a:off x="16465998" y="16554183"/>
-              <a:ext cx="1828800" cy="1828800"/>
-            </a:xfrm>
-            <a:prstGeom prst="rect">
-              <a:avLst/>
-            </a:prstGeom>
-            <a:solidFill>
-              <a:schemeClr val="bg1">
-                <a:lumMod val="65000"/>
-              </a:schemeClr>
-            </a:solidFill>
-            <a:ln>
-              <a:noFill/>
-            </a:ln>
-          </p:spPr>
-          <p:style>
-            <a:lnRef idx="2">
-              <a:schemeClr val="accent1">
-                <a:shade val="15000"/>
-              </a:schemeClr>
-            </a:lnRef>
-            <a:fillRef idx="1">
-              <a:schemeClr val="accent1"/>
-            </a:fillRef>
-            <a:effectRef idx="0">
-              <a:schemeClr val="accent1"/>
-            </a:effectRef>
-            <a:fontRef idx="minor">
-              <a:schemeClr val="lt1"/>
-            </a:fontRef>
-          </p:style>
-          <p:txBody>
-            <a:bodyPr rtlCol="0" anchor="ctr"/>
-            <a:lstStyle/>
-            <a:p>
-              <a:pPr algn="ctr"/>
-              <a:endParaRPr lang="en-US"/>
-            </a:p>
-          </p:txBody>
-        </p:sp>
-        <p:sp>
-          <p:nvSpPr>
-            <p:cNvPr id="37" name="Rectangle 36">
-              <a:extLst>
-                <a:ext uri="{FF2B5EF4-FFF2-40B4-BE49-F238E27FC236}">
-                  <a16:creationId xmlns:a16="http://schemas.microsoft.com/office/drawing/2014/main" id="{803D9F9B-1AA2-FA54-38FD-00E2859AC236}"/>
-                </a:ext>
-              </a:extLst>
-            </p:cNvPr>
-            <p:cNvSpPr/>
-            <p:nvPr/>
-          </p:nvSpPr>
-          <p:spPr>
-            <a:xfrm rot="10800000">
-              <a:off x="14637198" y="14725383"/>
-              <a:ext cx="1828800" cy="1828800"/>
-            </a:xfrm>
-            <a:prstGeom prst="rect">
-              <a:avLst/>
-            </a:prstGeom>
-            <a:solidFill>
-              <a:schemeClr val="bg1">
-                <a:lumMod val="65000"/>
-              </a:schemeClr>
-            </a:solidFill>
-            <a:ln>
-              <a:noFill/>
-            </a:ln>
-          </p:spPr>
-          <p:style>
-            <a:lnRef idx="2">
-              <a:schemeClr val="accent1">
-                <a:shade val="15000"/>
-              </a:schemeClr>
-            </a:lnRef>
-            <a:fillRef idx="1">
-              <a:schemeClr val="accent1"/>
-            </a:fillRef>
-            <a:effectRef idx="0">
-              <a:schemeClr val="accent1"/>
-            </a:effectRef>
-            <a:fontRef idx="minor">
-              <a:schemeClr val="lt1"/>
-            </a:fontRef>
-          </p:style>
-          <p:txBody>
-            <a:bodyPr rtlCol="0" anchor="ctr"/>
-            <a:lstStyle/>
-            <a:p>
-              <a:pPr algn="ctr"/>
-              <a:endParaRPr lang="en-US"/>
-            </a:p>
-          </p:txBody>
-        </p:sp>
-        <p:sp>
-          <p:nvSpPr>
-            <p:cNvPr id="38" name="Rectangle 37">
-              <a:extLst>
-                <a:ext uri="{FF2B5EF4-FFF2-40B4-BE49-F238E27FC236}">
-                  <a16:creationId xmlns:a16="http://schemas.microsoft.com/office/drawing/2014/main" id="{32E5D418-F3AA-0CFA-4238-9248A52D974A}"/>
-                </a:ext>
-              </a:extLst>
-            </p:cNvPr>
-            <p:cNvSpPr/>
-            <p:nvPr/>
-          </p:nvSpPr>
-          <p:spPr>
-            <a:xfrm rot="10800000">
-              <a:off x="12811797" y="12896583"/>
-              <a:ext cx="1828800" cy="1828800"/>
-            </a:xfrm>
-            <a:prstGeom prst="rect">
-              <a:avLst/>
-            </a:prstGeom>
-            <a:solidFill>
-              <a:schemeClr val="bg1">
-                <a:lumMod val="65000"/>
-              </a:schemeClr>
-            </a:solidFill>
-            <a:ln>
-              <a:noFill/>
-            </a:ln>
-          </p:spPr>
-          <p:style>
-            <a:lnRef idx="2">
-              <a:schemeClr val="accent1">
-                <a:shade val="15000"/>
-              </a:schemeClr>
-            </a:lnRef>
-            <a:fillRef idx="1">
-              <a:schemeClr val="accent1"/>
-            </a:fillRef>
-            <a:effectRef idx="0">
-              <a:schemeClr val="accent1"/>
-            </a:effectRef>
-            <a:fontRef idx="minor">
-              <a:schemeClr val="lt1"/>
-            </a:fontRef>
-          </p:style>
-          <p:txBody>
-            <a:bodyPr rtlCol="0" anchor="ctr"/>
-            <a:lstStyle/>
-            <a:p>
-              <a:pPr algn="ctr"/>
-              <a:endParaRPr lang="en-US"/>
-            </a:p>
-          </p:txBody>
-        </p:sp>
-        <p:sp>
-          <p:nvSpPr>
-            <p:cNvPr id="39" name="Rectangle 38">
-              <a:extLst>
-                <a:ext uri="{FF2B5EF4-FFF2-40B4-BE49-F238E27FC236}">
-                  <a16:creationId xmlns:a16="http://schemas.microsoft.com/office/drawing/2014/main" id="{AFFDC413-06A1-EA19-0F78-24BA4E41C63F}"/>
-                </a:ext>
-              </a:extLst>
-            </p:cNvPr>
-            <p:cNvSpPr/>
-            <p:nvPr/>
-          </p:nvSpPr>
-          <p:spPr>
-            <a:xfrm rot="10800000">
-              <a:off x="10972800" y="14725383"/>
-              <a:ext cx="1828800" cy="1828800"/>
-            </a:xfrm>
-            <a:prstGeom prst="rect">
-              <a:avLst/>
-            </a:prstGeom>
-            <a:solidFill>
-              <a:schemeClr val="bg1">
-                <a:lumMod val="65000"/>
-              </a:schemeClr>
-            </a:solidFill>
-            <a:ln>
-              <a:noFill/>
-            </a:ln>
-          </p:spPr>
-          <p:style>
-            <a:lnRef idx="2">
-              <a:schemeClr val="accent1">
-                <a:shade val="15000"/>
-              </a:schemeClr>
-            </a:lnRef>
-            <a:fillRef idx="1">
-              <a:schemeClr val="accent1"/>
-            </a:fillRef>
-            <a:effectRef idx="0">
-              <a:schemeClr val="accent1"/>
-            </a:effectRef>
-            <a:fontRef idx="minor">
-              <a:schemeClr val="lt1"/>
-            </a:fontRef>
-          </p:style>
-          <p:txBody>
-            <a:bodyPr rtlCol="0" anchor="ctr"/>
-            <a:lstStyle/>
-            <a:p>
-              <a:pPr algn="ctr"/>
-              <a:endParaRPr lang="en-US"/>
-            </a:p>
-          </p:txBody>
-        </p:sp>
-        <p:sp>
-          <p:nvSpPr>
-            <p:cNvPr id="40" name="Rectangle 39">
-              <a:extLst>
-                <a:ext uri="{FF2B5EF4-FFF2-40B4-BE49-F238E27FC236}">
-                  <a16:creationId xmlns:a16="http://schemas.microsoft.com/office/drawing/2014/main" id="{9B6829A3-7189-F1AE-A801-564EFA7136EC}"/>
-                </a:ext>
-              </a:extLst>
-            </p:cNvPr>
-            <p:cNvSpPr/>
-            <p:nvPr/>
-          </p:nvSpPr>
-          <p:spPr>
-            <a:xfrm rot="10800000">
-              <a:off x="9144000" y="12876833"/>
-              <a:ext cx="1828800" cy="1828800"/>
-            </a:xfrm>
-            <a:prstGeom prst="rect">
-              <a:avLst/>
-            </a:prstGeom>
-            <a:solidFill>
-              <a:schemeClr val="bg1">
-                <a:lumMod val="65000"/>
-              </a:schemeClr>
-            </a:solidFill>
-            <a:ln>
-              <a:noFill/>
-            </a:ln>
-          </p:spPr>
-          <p:style>
-            <a:lnRef idx="2">
-              <a:schemeClr val="accent1">
-                <a:shade val="15000"/>
-              </a:schemeClr>
-            </a:lnRef>
-            <a:fillRef idx="1">
-              <a:schemeClr val="accent1"/>
-            </a:fillRef>
-            <a:effectRef idx="0">
-              <a:schemeClr val="accent1"/>
-            </a:effectRef>
-            <a:fontRef idx="minor">
-              <a:schemeClr val="lt1"/>
-            </a:fontRef>
-          </p:style>
-          <p:txBody>
-            <a:bodyPr rtlCol="0" anchor="ctr"/>
-            <a:lstStyle/>
-            <a:p>
-              <a:pPr algn="ctr"/>
-              <a:endParaRPr lang="en-US"/>
-            </a:p>
-          </p:txBody>
-        </p:sp>
-        <p:sp>
-          <p:nvSpPr>
-            <p:cNvPr id="41" name="Rectangle 40">
-              <a:extLst>
-                <a:ext uri="{FF2B5EF4-FFF2-40B4-BE49-F238E27FC236}">
-                  <a16:creationId xmlns:a16="http://schemas.microsoft.com/office/drawing/2014/main" id="{4114B73E-05C4-34D2-45E9-77E76AFB1F68}"/>
-                </a:ext>
-              </a:extLst>
-            </p:cNvPr>
-            <p:cNvSpPr/>
-            <p:nvPr/>
-          </p:nvSpPr>
-          <p:spPr>
-            <a:xfrm rot="10800000">
-              <a:off x="7321998" y="14725383"/>
-              <a:ext cx="1828800" cy="1828800"/>
-            </a:xfrm>
-            <a:prstGeom prst="rect">
-              <a:avLst/>
-            </a:prstGeom>
-            <a:solidFill>
-              <a:schemeClr val="bg1">
-                <a:lumMod val="65000"/>
-              </a:schemeClr>
-            </a:solidFill>
-            <a:ln>
-              <a:noFill/>
-            </a:ln>
-          </p:spPr>
-          <p:style>
-            <a:lnRef idx="2">
-              <a:schemeClr val="accent1">
-                <a:shade val="15000"/>
-              </a:schemeClr>
-            </a:lnRef>
-            <a:fillRef idx="1">
-              <a:schemeClr val="accent1"/>
-            </a:fillRef>
-            <a:effectRef idx="0">
-              <a:schemeClr val="accent1"/>
-            </a:effectRef>
-            <a:fontRef idx="minor">
-              <a:schemeClr val="lt1"/>
-            </a:fontRef>
-          </p:style>
-          <p:txBody>
-            <a:bodyPr rtlCol="0" anchor="ctr"/>
-            <a:lstStyle/>
-            <a:p>
-              <a:pPr algn="ctr"/>
-              <a:endParaRPr lang="en-US"/>
-            </a:p>
-          </p:txBody>
-        </p:sp>
-        <p:sp>
-          <p:nvSpPr>
-            <p:cNvPr id="42" name="Rectangle 41">
-              <a:extLst>
-                <a:ext uri="{FF2B5EF4-FFF2-40B4-BE49-F238E27FC236}">
-                  <a16:creationId xmlns:a16="http://schemas.microsoft.com/office/drawing/2014/main" id="{4FD336DA-7A96-9E41-749C-2E5ED6436024}"/>
-                </a:ext>
-              </a:extLst>
-            </p:cNvPr>
-            <p:cNvSpPr/>
-            <p:nvPr/>
-          </p:nvSpPr>
-          <p:spPr>
-            <a:xfrm rot="10800000">
-              <a:off x="5482866" y="16554183"/>
-              <a:ext cx="1828800" cy="1828800"/>
-            </a:xfrm>
-            <a:prstGeom prst="rect">
-              <a:avLst/>
-            </a:prstGeom>
-            <a:solidFill>
-              <a:schemeClr val="bg1">
-                <a:lumMod val="65000"/>
-              </a:schemeClr>
-            </a:solidFill>
-            <a:ln>
-              <a:noFill/>
-            </a:ln>
-          </p:spPr>
-          <p:style>
-            <a:lnRef idx="2">
-              <a:schemeClr val="accent1">
-                <a:shade val="15000"/>
-              </a:schemeClr>
-            </a:lnRef>
-            <a:fillRef idx="1">
-              <a:schemeClr val="accent1"/>
-            </a:fillRef>
-            <a:effectRef idx="0">
-              <a:schemeClr val="accent1"/>
-            </a:effectRef>
-            <a:fontRef idx="minor">
-              <a:schemeClr val="lt1"/>
-            </a:fontRef>
-          </p:style>
-          <p:txBody>
-            <a:bodyPr rtlCol="0" anchor="ctr"/>
-            <a:lstStyle/>
-            <a:p>
-              <a:pPr algn="ctr"/>
-              <a:endParaRPr lang="en-US"/>
-            </a:p>
-          </p:txBody>
-        </p:sp>
-        <p:sp>
-          <p:nvSpPr>
-            <p:cNvPr id="43" name="Rectangle 42">
-              <a:extLst>
-                <a:ext uri="{FF2B5EF4-FFF2-40B4-BE49-F238E27FC236}">
-                  <a16:creationId xmlns:a16="http://schemas.microsoft.com/office/drawing/2014/main" id="{55F9B519-3307-5585-A8D6-078D716E15BC}"/>
-                </a:ext>
-              </a:extLst>
-            </p:cNvPr>
-            <p:cNvSpPr/>
-            <p:nvPr/>
-          </p:nvSpPr>
-          <p:spPr>
-            <a:xfrm rot="10800000">
-              <a:off x="3685062" y="14725383"/>
-              <a:ext cx="1828800" cy="1828800"/>
-            </a:xfrm>
-            <a:prstGeom prst="rect">
-              <a:avLst/>
-            </a:prstGeom>
-            <a:solidFill>
-              <a:schemeClr val="bg1">
-                <a:lumMod val="65000"/>
-              </a:schemeClr>
-            </a:solidFill>
-            <a:ln>
-              <a:noFill/>
-            </a:ln>
-          </p:spPr>
-          <p:style>
-            <a:lnRef idx="2">
-              <a:schemeClr val="accent1">
-                <a:shade val="15000"/>
-              </a:schemeClr>
-            </a:lnRef>
-            <a:fillRef idx="1">
-              <a:schemeClr val="accent1"/>
-            </a:fillRef>
-            <a:effectRef idx="0">
-              <a:schemeClr val="accent1"/>
-            </a:effectRef>
-            <a:fontRef idx="minor">
-              <a:schemeClr val="lt1"/>
-            </a:fontRef>
-          </p:style>
-          <p:txBody>
-            <a:bodyPr rtlCol="0" anchor="ctr"/>
-            <a:lstStyle/>
-            <a:p>
-              <a:pPr algn="ctr"/>
-              <a:endParaRPr lang="en-US"/>
-            </a:p>
-          </p:txBody>
-        </p:sp>
-        <p:sp>
-          <p:nvSpPr>
-            <p:cNvPr id="44" name="Rectangle 43">
-              <a:extLst>
-                <a:ext uri="{FF2B5EF4-FFF2-40B4-BE49-F238E27FC236}">
-                  <a16:creationId xmlns:a16="http://schemas.microsoft.com/office/drawing/2014/main" id="{E0C4C903-D7A4-5BF2-4054-B795EFD04561}"/>
-                </a:ext>
-              </a:extLst>
-            </p:cNvPr>
-            <p:cNvSpPr/>
-            <p:nvPr/>
-          </p:nvSpPr>
-          <p:spPr>
-            <a:xfrm rot="10800000">
-              <a:off x="1832199" y="12867743"/>
-              <a:ext cx="1828800" cy="1828800"/>
-            </a:xfrm>
-            <a:prstGeom prst="rect">
-              <a:avLst/>
-            </a:prstGeom>
-            <a:solidFill>
-              <a:schemeClr val="bg1">
-                <a:lumMod val="65000"/>
-              </a:schemeClr>
-            </a:solidFill>
-            <a:ln>
-              <a:noFill/>
-            </a:ln>
-          </p:spPr>
-          <p:style>
-            <a:lnRef idx="2">
-              <a:schemeClr val="accent1">
-                <a:shade val="15000"/>
-              </a:schemeClr>
-            </a:lnRef>
-            <a:fillRef idx="1">
-              <a:schemeClr val="accent1"/>
-            </a:fillRef>
-            <a:effectRef idx="0">
-              <a:schemeClr val="accent1"/>
-            </a:effectRef>
-            <a:fontRef idx="minor">
-              <a:schemeClr val="lt1"/>
-            </a:fontRef>
-          </p:style>
-          <p:txBody>
-            <a:bodyPr rtlCol="0" anchor="ctr"/>
-            <a:lstStyle/>
-            <a:p>
-              <a:pPr algn="ctr"/>
-              <a:endParaRPr lang="en-US"/>
-            </a:p>
-          </p:txBody>
-        </p:sp>
-        <p:sp>
-          <p:nvSpPr>
-            <p:cNvPr id="45" name="Rectangle 44">
-              <a:extLst>
-                <a:ext uri="{FF2B5EF4-FFF2-40B4-BE49-F238E27FC236}">
-                  <a16:creationId xmlns:a16="http://schemas.microsoft.com/office/drawing/2014/main" id="{4E4C54B8-9CBD-8F76-C6CF-CEEDBF131F42}"/>
-                </a:ext>
-              </a:extLst>
-            </p:cNvPr>
-            <p:cNvSpPr/>
-            <p:nvPr/>
-          </p:nvSpPr>
-          <p:spPr>
-            <a:xfrm rot="10800000">
-              <a:off x="1832199" y="16554183"/>
-              <a:ext cx="1828800" cy="1828800"/>
-            </a:xfrm>
-            <a:prstGeom prst="rect">
-              <a:avLst/>
-            </a:prstGeom>
-            <a:solidFill>
-              <a:schemeClr val="bg1">
-                <a:lumMod val="65000"/>
-              </a:schemeClr>
-            </a:solidFill>
-            <a:ln>
-              <a:noFill/>
-            </a:ln>
-          </p:spPr>
-          <p:style>
-            <a:lnRef idx="2">
-              <a:schemeClr val="accent1">
-                <a:shade val="15000"/>
-              </a:schemeClr>
-            </a:lnRef>
-            <a:fillRef idx="1">
-              <a:schemeClr val="accent1"/>
-            </a:fillRef>
-            <a:effectRef idx="0">
-              <a:schemeClr val="accent1"/>
-            </a:effectRef>
-            <a:fontRef idx="minor">
-              <a:schemeClr val="lt1"/>
-            </a:fontRef>
-          </p:style>
-          <p:txBody>
-            <a:bodyPr rtlCol="0" anchor="ctr"/>
-            <a:lstStyle/>
-            <a:p>
-              <a:pPr algn="ctr"/>
-              <a:endParaRPr lang="en-US"/>
-            </a:p>
-          </p:txBody>
-        </p:sp>
-        <p:sp>
-          <p:nvSpPr>
-            <p:cNvPr id="46" name="Rectangle 45">
-              <a:extLst>
-                <a:ext uri="{FF2B5EF4-FFF2-40B4-BE49-F238E27FC236}">
-                  <a16:creationId xmlns:a16="http://schemas.microsoft.com/office/drawing/2014/main" id="{2BE43D93-5AFA-F3F2-388E-B1279F6AA8BE}"/>
-                </a:ext>
-              </a:extLst>
-            </p:cNvPr>
-            <p:cNvSpPr/>
-            <p:nvPr/>
-          </p:nvSpPr>
-          <p:spPr>
-            <a:xfrm rot="10800000">
-              <a:off x="12808398" y="12876833"/>
-              <a:ext cx="1828800" cy="1828800"/>
-            </a:xfrm>
-            <a:prstGeom prst="rect">
-              <a:avLst/>
-            </a:prstGeom>
-            <a:solidFill>
-              <a:schemeClr val="bg1">
-                <a:lumMod val="65000"/>
-              </a:schemeClr>
-            </a:solidFill>
-            <a:ln>
-              <a:noFill/>
-            </a:ln>
-          </p:spPr>
-          <p:style>
-            <a:lnRef idx="2">
-              <a:schemeClr val="accent1">
-                <a:shade val="15000"/>
-              </a:schemeClr>
-            </a:lnRef>
-            <a:fillRef idx="1">
-              <a:schemeClr val="accent1"/>
-            </a:fillRef>
-            <a:effectRef idx="0">
-              <a:schemeClr val="accent1"/>
-            </a:effectRef>
-            <a:fontRef idx="minor">
-              <a:schemeClr val="lt1"/>
-            </a:fontRef>
-          </p:style>
-          <p:txBody>
-            <a:bodyPr rtlCol="0" anchor="ctr"/>
-            <a:lstStyle/>
-            <a:p>
-              <a:pPr algn="ctr"/>
-              <a:endParaRPr lang="en-US"/>
-            </a:p>
-          </p:txBody>
-        </p:sp>
-        <p:sp>
-          <p:nvSpPr>
-            <p:cNvPr id="47" name="Rectangle 46">
-              <a:extLst>
-                <a:ext uri="{FF2B5EF4-FFF2-40B4-BE49-F238E27FC236}">
-                  <a16:creationId xmlns:a16="http://schemas.microsoft.com/office/drawing/2014/main" id="{8B9DDEB3-0AB2-6417-6D71-79249CDC4D80}"/>
-                </a:ext>
-              </a:extLst>
-            </p:cNvPr>
-            <p:cNvSpPr/>
-            <p:nvPr/>
-          </p:nvSpPr>
-          <p:spPr>
-            <a:xfrm rot="10800000">
-              <a:off x="9161130" y="16554183"/>
-              <a:ext cx="1828800" cy="1828800"/>
-            </a:xfrm>
-            <a:prstGeom prst="rect">
-              <a:avLst/>
-            </a:prstGeom>
-            <a:solidFill>
-              <a:schemeClr val="bg1">
-                <a:lumMod val="65000"/>
-              </a:schemeClr>
-            </a:solidFill>
-            <a:ln>
-              <a:noFill/>
-            </a:ln>
-          </p:spPr>
-          <p:style>
-            <a:lnRef idx="2">
-              <a:schemeClr val="accent1">
-                <a:shade val="15000"/>
-              </a:schemeClr>
-            </a:lnRef>
-            <a:fillRef idx="1">
-              <a:schemeClr val="accent1"/>
-            </a:fillRef>
-            <a:effectRef idx="0">
-              <a:schemeClr val="accent1"/>
-            </a:effectRef>
-            <a:fontRef idx="minor">
-              <a:schemeClr val="lt1"/>
-            </a:fontRef>
-          </p:style>
-          <p:txBody>
-            <a:bodyPr rtlCol="0" anchor="ctr"/>
-            <a:lstStyle/>
-            <a:p>
-              <a:pPr algn="ctr"/>
-              <a:endParaRPr lang="en-US"/>
-            </a:p>
-          </p:txBody>
-        </p:sp>
-        <p:sp>
-          <p:nvSpPr>
-            <p:cNvPr id="48" name="Rectangle 47">
-              <a:extLst>
-                <a:ext uri="{FF2B5EF4-FFF2-40B4-BE49-F238E27FC236}">
-                  <a16:creationId xmlns:a16="http://schemas.microsoft.com/office/drawing/2014/main" id="{B63A2A09-0592-8E91-8B48-B76426ECE375}"/>
-                </a:ext>
-              </a:extLst>
-            </p:cNvPr>
-            <p:cNvSpPr/>
-            <p:nvPr/>
-          </p:nvSpPr>
-          <p:spPr>
-            <a:xfrm rot="10800000">
-              <a:off x="0" y="14696543"/>
-              <a:ext cx="1828800" cy="1828800"/>
-            </a:xfrm>
-            <a:prstGeom prst="rect">
-              <a:avLst/>
-            </a:prstGeom>
-            <a:solidFill>
-              <a:schemeClr val="bg1">
-                <a:lumMod val="65000"/>
-              </a:schemeClr>
-            </a:solidFill>
-            <a:ln>
-              <a:noFill/>
-            </a:ln>
-          </p:spPr>
-          <p:style>
-            <a:lnRef idx="2">
-              <a:schemeClr val="accent1">
-                <a:shade val="15000"/>
-              </a:schemeClr>
-            </a:lnRef>
-            <a:fillRef idx="1">
-              <a:schemeClr val="accent1"/>
-            </a:fillRef>
-            <a:effectRef idx="0">
-              <a:schemeClr val="accent1"/>
-            </a:effectRef>
-            <a:fontRef idx="minor">
-              <a:schemeClr val="lt1"/>
-            </a:fontRef>
-          </p:style>
-          <p:txBody>
-            <a:bodyPr rtlCol="0" anchor="ctr"/>
-            <a:lstStyle/>
-            <a:p>
-              <a:pPr algn="ctr"/>
-              <a:endParaRPr lang="en-US"/>
-            </a:p>
-          </p:txBody>
-        </p:sp>
-        <p:sp>
-          <p:nvSpPr>
-            <p:cNvPr id="49" name="Rectangle 48">
-              <a:extLst>
-                <a:ext uri="{FF2B5EF4-FFF2-40B4-BE49-F238E27FC236}">
-                  <a16:creationId xmlns:a16="http://schemas.microsoft.com/office/drawing/2014/main" id="{7385E990-2A37-A42C-7C1A-9E3C1654F54E}"/>
-                </a:ext>
-              </a:extLst>
-            </p:cNvPr>
-            <p:cNvSpPr/>
-            <p:nvPr/>
-          </p:nvSpPr>
-          <p:spPr>
-            <a:xfrm rot="10800000">
-              <a:off x="12811814" y="16525343"/>
-              <a:ext cx="1828800" cy="1828800"/>
-            </a:xfrm>
-            <a:prstGeom prst="rect">
-              <a:avLst/>
-            </a:prstGeom>
-            <a:solidFill>
-              <a:schemeClr val="bg1">
-                <a:lumMod val="65000"/>
-              </a:schemeClr>
-            </a:solidFill>
-            <a:ln>
-              <a:noFill/>
-            </a:ln>
-          </p:spPr>
-          <p:style>
-            <a:lnRef idx="2">
-              <a:schemeClr val="accent1">
-                <a:shade val="15000"/>
-              </a:schemeClr>
-            </a:lnRef>
-            <a:fillRef idx="1">
-              <a:schemeClr val="accent1"/>
-            </a:fillRef>
-            <a:effectRef idx="0">
-              <a:schemeClr val="accent1"/>
-            </a:effectRef>
-            <a:fontRef idx="minor">
-              <a:schemeClr val="lt1"/>
-            </a:fontRef>
-          </p:style>
-          <p:txBody>
-            <a:bodyPr rtlCol="0" anchor="ctr"/>
-            <a:lstStyle/>
-            <a:p>
-              <a:pPr algn="ctr"/>
-              <a:endParaRPr lang="en-US"/>
-            </a:p>
-          </p:txBody>
-        </p:sp>
-      </p:grpSp>
+          <a:prstGeom prst="rect">
+            <a:avLst/>
+          </a:prstGeom>
+          <a:solidFill>
+            <a:schemeClr val="bg1">
+              <a:lumMod val="75000"/>
+            </a:schemeClr>
+          </a:solidFill>
+          <a:ln>
+            <a:noFill/>
+          </a:ln>
+        </p:spPr>
+        <p:style>
+          <a:lnRef idx="2">
+            <a:schemeClr val="accent1">
+              <a:shade val="15000"/>
+            </a:schemeClr>
+          </a:lnRef>
+          <a:fillRef idx="1">
+            <a:schemeClr val="accent1"/>
+          </a:fillRef>
+          <a:effectRef idx="0">
+            <a:schemeClr val="accent1"/>
+          </a:effectRef>
+          <a:fontRef idx="minor">
+            <a:schemeClr val="lt1"/>
+          </a:fontRef>
+        </p:style>
+        <p:txBody>
+          <a:bodyPr rtlCol="0" anchor="ctr"/>
+          <a:lstStyle/>
+          <a:p>
+            <a:pPr algn="ctr"/>
+            <a:endParaRPr lang="en-US"/>
+          </a:p>
+        </p:txBody>
+      </p:sp>
+      <p:sp>
+        <p:nvSpPr>
+          <p:cNvPr id="36" name="Rectangle 35">
+            <a:extLst>
+              <a:ext uri="{FF2B5EF4-FFF2-40B4-BE49-F238E27FC236}">
+                <a16:creationId xmlns:a16="http://schemas.microsoft.com/office/drawing/2014/main" id="{847A4DFB-999D-7EFF-B8C3-3F0D00759642}"/>
+              </a:ext>
+            </a:extLst>
+          </p:cNvPr>
+          <p:cNvSpPr/>
+          <p:nvPr/>
+        </p:nvSpPr>
+        <p:spPr>
+          <a:xfrm rot="10800000">
+            <a:off x="16469398" y="16459200"/>
+            <a:ext cx="1828800" cy="1828800"/>
+          </a:xfrm>
+          <a:prstGeom prst="rect">
+            <a:avLst/>
+          </a:prstGeom>
+          <a:solidFill>
+            <a:schemeClr val="bg1">
+              <a:lumMod val="65000"/>
+            </a:schemeClr>
+          </a:solidFill>
+          <a:ln>
+            <a:noFill/>
+          </a:ln>
+        </p:spPr>
+        <p:style>
+          <a:lnRef idx="2">
+            <a:schemeClr val="accent1">
+              <a:shade val="15000"/>
+            </a:schemeClr>
+          </a:lnRef>
+          <a:fillRef idx="1">
+            <a:schemeClr val="accent1"/>
+          </a:fillRef>
+          <a:effectRef idx="0">
+            <a:schemeClr val="accent1"/>
+          </a:effectRef>
+          <a:fontRef idx="minor">
+            <a:schemeClr val="lt1"/>
+          </a:fontRef>
+        </p:style>
+        <p:txBody>
+          <a:bodyPr rtlCol="0" anchor="ctr"/>
+          <a:lstStyle/>
+          <a:p>
+            <a:pPr algn="ctr"/>
+            <a:endParaRPr lang="en-US"/>
+          </a:p>
+        </p:txBody>
+      </p:sp>
+      <p:sp>
+        <p:nvSpPr>
+          <p:cNvPr id="37" name="Rectangle 36">
+            <a:extLst>
+              <a:ext uri="{FF2B5EF4-FFF2-40B4-BE49-F238E27FC236}">
+                <a16:creationId xmlns:a16="http://schemas.microsoft.com/office/drawing/2014/main" id="{803D9F9B-1AA2-FA54-38FD-00E2859AC236}"/>
+              </a:ext>
+            </a:extLst>
+          </p:cNvPr>
+          <p:cNvSpPr/>
+          <p:nvPr/>
+        </p:nvSpPr>
+        <p:spPr>
+          <a:xfrm rot="10800000">
+            <a:off x="14640598" y="14630400"/>
+            <a:ext cx="1828800" cy="1828800"/>
+          </a:xfrm>
+          <a:prstGeom prst="rect">
+            <a:avLst/>
+          </a:prstGeom>
+          <a:solidFill>
+            <a:schemeClr val="bg1">
+              <a:lumMod val="65000"/>
+            </a:schemeClr>
+          </a:solidFill>
+          <a:ln>
+            <a:noFill/>
+          </a:ln>
+        </p:spPr>
+        <p:style>
+          <a:lnRef idx="2">
+            <a:schemeClr val="accent1">
+              <a:shade val="15000"/>
+            </a:schemeClr>
+          </a:lnRef>
+          <a:fillRef idx="1">
+            <a:schemeClr val="accent1"/>
+          </a:fillRef>
+          <a:effectRef idx="0">
+            <a:schemeClr val="accent1"/>
+          </a:effectRef>
+          <a:fontRef idx="minor">
+            <a:schemeClr val="lt1"/>
+          </a:fontRef>
+        </p:style>
+        <p:txBody>
+          <a:bodyPr rtlCol="0" anchor="ctr"/>
+          <a:lstStyle/>
+          <a:p>
+            <a:pPr algn="ctr"/>
+            <a:endParaRPr lang="en-US"/>
+          </a:p>
+        </p:txBody>
+      </p:sp>
+      <p:sp>
+        <p:nvSpPr>
+          <p:cNvPr id="38" name="Rectangle 37">
+            <a:extLst>
+              <a:ext uri="{FF2B5EF4-FFF2-40B4-BE49-F238E27FC236}">
+                <a16:creationId xmlns:a16="http://schemas.microsoft.com/office/drawing/2014/main" id="{32E5D418-F3AA-0CFA-4238-9248A52D974A}"/>
+              </a:ext>
+            </a:extLst>
+          </p:cNvPr>
+          <p:cNvSpPr/>
+          <p:nvPr/>
+        </p:nvSpPr>
+        <p:spPr>
+          <a:xfrm rot="10800000">
+            <a:off x="12815197" y="12801600"/>
+            <a:ext cx="1828800" cy="1828800"/>
+          </a:xfrm>
+          <a:prstGeom prst="rect">
+            <a:avLst/>
+          </a:prstGeom>
+          <a:solidFill>
+            <a:schemeClr val="bg1">
+              <a:lumMod val="65000"/>
+            </a:schemeClr>
+          </a:solidFill>
+          <a:ln>
+            <a:noFill/>
+          </a:ln>
+        </p:spPr>
+        <p:style>
+          <a:lnRef idx="2">
+            <a:schemeClr val="accent1">
+              <a:shade val="15000"/>
+            </a:schemeClr>
+          </a:lnRef>
+          <a:fillRef idx="1">
+            <a:schemeClr val="accent1"/>
+          </a:fillRef>
+          <a:effectRef idx="0">
+            <a:schemeClr val="accent1"/>
+          </a:effectRef>
+          <a:fontRef idx="minor">
+            <a:schemeClr val="lt1"/>
+          </a:fontRef>
+        </p:style>
+        <p:txBody>
+          <a:bodyPr rtlCol="0" anchor="ctr"/>
+          <a:lstStyle/>
+          <a:p>
+            <a:pPr algn="ctr"/>
+            <a:endParaRPr lang="en-US"/>
+          </a:p>
+        </p:txBody>
+      </p:sp>
+      <p:sp>
+        <p:nvSpPr>
+          <p:cNvPr id="39" name="Rectangle 38">
+            <a:extLst>
+              <a:ext uri="{FF2B5EF4-FFF2-40B4-BE49-F238E27FC236}">
+                <a16:creationId xmlns:a16="http://schemas.microsoft.com/office/drawing/2014/main" id="{AFFDC413-06A1-EA19-0F78-24BA4E41C63F}"/>
+              </a:ext>
+            </a:extLst>
+          </p:cNvPr>
+          <p:cNvSpPr/>
+          <p:nvPr/>
+        </p:nvSpPr>
+        <p:spPr>
+          <a:xfrm rot="10800000">
+            <a:off x="10976200" y="14630400"/>
+            <a:ext cx="1828800" cy="1828800"/>
+          </a:xfrm>
+          <a:prstGeom prst="rect">
+            <a:avLst/>
+          </a:prstGeom>
+          <a:solidFill>
+            <a:schemeClr val="bg1">
+              <a:lumMod val="65000"/>
+            </a:schemeClr>
+          </a:solidFill>
+          <a:ln>
+            <a:noFill/>
+          </a:ln>
+        </p:spPr>
+        <p:style>
+          <a:lnRef idx="2">
+            <a:schemeClr val="accent1">
+              <a:shade val="15000"/>
+            </a:schemeClr>
+          </a:lnRef>
+          <a:fillRef idx="1">
+            <a:schemeClr val="accent1"/>
+          </a:fillRef>
+          <a:effectRef idx="0">
+            <a:schemeClr val="accent1"/>
+          </a:effectRef>
+          <a:fontRef idx="minor">
+            <a:schemeClr val="lt1"/>
+          </a:fontRef>
+        </p:style>
+        <p:txBody>
+          <a:bodyPr rtlCol="0" anchor="ctr"/>
+          <a:lstStyle/>
+          <a:p>
+            <a:pPr algn="ctr"/>
+            <a:endParaRPr lang="en-US"/>
+          </a:p>
+        </p:txBody>
+      </p:sp>
+      <p:sp>
+        <p:nvSpPr>
+          <p:cNvPr id="40" name="Rectangle 39">
+            <a:extLst>
+              <a:ext uri="{FF2B5EF4-FFF2-40B4-BE49-F238E27FC236}">
+                <a16:creationId xmlns:a16="http://schemas.microsoft.com/office/drawing/2014/main" id="{9B6829A3-7189-F1AE-A801-564EFA7136EC}"/>
+              </a:ext>
+            </a:extLst>
+          </p:cNvPr>
+          <p:cNvSpPr/>
+          <p:nvPr/>
+        </p:nvSpPr>
+        <p:spPr>
+          <a:xfrm rot="10800000">
+            <a:off x="9147400" y="12781850"/>
+            <a:ext cx="1828800" cy="1828800"/>
+          </a:xfrm>
+          <a:prstGeom prst="rect">
+            <a:avLst/>
+          </a:prstGeom>
+          <a:solidFill>
+            <a:schemeClr val="bg1">
+              <a:lumMod val="65000"/>
+            </a:schemeClr>
+          </a:solidFill>
+          <a:ln>
+            <a:noFill/>
+          </a:ln>
+        </p:spPr>
+        <p:style>
+          <a:lnRef idx="2">
+            <a:schemeClr val="accent1">
+              <a:shade val="15000"/>
+            </a:schemeClr>
+          </a:lnRef>
+          <a:fillRef idx="1">
+            <a:schemeClr val="accent1"/>
+          </a:fillRef>
+          <a:effectRef idx="0">
+            <a:schemeClr val="accent1"/>
+          </a:effectRef>
+          <a:fontRef idx="minor">
+            <a:schemeClr val="lt1"/>
+          </a:fontRef>
+        </p:style>
+        <p:txBody>
+          <a:bodyPr rtlCol="0" anchor="ctr"/>
+          <a:lstStyle/>
+          <a:p>
+            <a:pPr algn="ctr"/>
+            <a:endParaRPr lang="en-US"/>
+          </a:p>
+        </p:txBody>
+      </p:sp>
+      <p:sp>
+        <p:nvSpPr>
+          <p:cNvPr id="41" name="Rectangle 40">
+            <a:extLst>
+              <a:ext uri="{FF2B5EF4-FFF2-40B4-BE49-F238E27FC236}">
+                <a16:creationId xmlns:a16="http://schemas.microsoft.com/office/drawing/2014/main" id="{4114B73E-05C4-34D2-45E9-77E76AFB1F68}"/>
+              </a:ext>
+            </a:extLst>
+          </p:cNvPr>
+          <p:cNvSpPr/>
+          <p:nvPr/>
+        </p:nvSpPr>
+        <p:spPr>
+          <a:xfrm rot="10800000">
+            <a:off x="7325398" y="14630400"/>
+            <a:ext cx="1828800" cy="1828800"/>
+          </a:xfrm>
+          <a:prstGeom prst="rect">
+            <a:avLst/>
+          </a:prstGeom>
+          <a:solidFill>
+            <a:schemeClr val="bg1">
+              <a:lumMod val="65000"/>
+            </a:schemeClr>
+          </a:solidFill>
+          <a:ln>
+            <a:noFill/>
+          </a:ln>
+        </p:spPr>
+        <p:style>
+          <a:lnRef idx="2">
+            <a:schemeClr val="accent1">
+              <a:shade val="15000"/>
+            </a:schemeClr>
+          </a:lnRef>
+          <a:fillRef idx="1">
+            <a:schemeClr val="accent1"/>
+          </a:fillRef>
+          <a:effectRef idx="0">
+            <a:schemeClr val="accent1"/>
+          </a:effectRef>
+          <a:fontRef idx="minor">
+            <a:schemeClr val="lt1"/>
+          </a:fontRef>
+        </p:style>
+        <p:txBody>
+          <a:bodyPr rtlCol="0" anchor="ctr"/>
+          <a:lstStyle/>
+          <a:p>
+            <a:pPr algn="ctr"/>
+            <a:endParaRPr lang="en-US"/>
+          </a:p>
+        </p:txBody>
+      </p:sp>
+      <p:sp>
+        <p:nvSpPr>
+          <p:cNvPr id="42" name="Rectangle 41">
+            <a:extLst>
+              <a:ext uri="{FF2B5EF4-FFF2-40B4-BE49-F238E27FC236}">
+                <a16:creationId xmlns:a16="http://schemas.microsoft.com/office/drawing/2014/main" id="{4FD336DA-7A96-9E41-749C-2E5ED6436024}"/>
+              </a:ext>
+            </a:extLst>
+          </p:cNvPr>
+          <p:cNvSpPr/>
+          <p:nvPr/>
+        </p:nvSpPr>
+        <p:spPr>
+          <a:xfrm rot="10800000">
+            <a:off x="5486266" y="16459200"/>
+            <a:ext cx="1828800" cy="1828800"/>
+          </a:xfrm>
+          <a:prstGeom prst="rect">
+            <a:avLst/>
+          </a:prstGeom>
+          <a:solidFill>
+            <a:schemeClr val="bg1">
+              <a:lumMod val="65000"/>
+            </a:schemeClr>
+          </a:solidFill>
+          <a:ln>
+            <a:noFill/>
+          </a:ln>
+        </p:spPr>
+        <p:style>
+          <a:lnRef idx="2">
+            <a:schemeClr val="accent1">
+              <a:shade val="15000"/>
+            </a:schemeClr>
+          </a:lnRef>
+          <a:fillRef idx="1">
+            <a:schemeClr val="accent1"/>
+          </a:fillRef>
+          <a:effectRef idx="0">
+            <a:schemeClr val="accent1"/>
+          </a:effectRef>
+          <a:fontRef idx="minor">
+            <a:schemeClr val="lt1"/>
+          </a:fontRef>
+        </p:style>
+        <p:txBody>
+          <a:bodyPr rtlCol="0" anchor="ctr"/>
+          <a:lstStyle/>
+          <a:p>
+            <a:pPr algn="ctr"/>
+            <a:endParaRPr lang="en-US"/>
+          </a:p>
+        </p:txBody>
+      </p:sp>
+      <p:sp>
+        <p:nvSpPr>
+          <p:cNvPr id="43" name="Rectangle 42">
+            <a:extLst>
+              <a:ext uri="{FF2B5EF4-FFF2-40B4-BE49-F238E27FC236}">
+                <a16:creationId xmlns:a16="http://schemas.microsoft.com/office/drawing/2014/main" id="{55F9B519-3307-5585-A8D6-078D716E15BC}"/>
+              </a:ext>
+            </a:extLst>
+          </p:cNvPr>
+          <p:cNvSpPr/>
+          <p:nvPr/>
+        </p:nvSpPr>
+        <p:spPr>
+          <a:xfrm rot="10800000">
+            <a:off x="3688462" y="14630400"/>
+            <a:ext cx="1828800" cy="1828800"/>
+          </a:xfrm>
+          <a:prstGeom prst="rect">
+            <a:avLst/>
+          </a:prstGeom>
+          <a:solidFill>
+            <a:schemeClr val="bg1">
+              <a:lumMod val="65000"/>
+            </a:schemeClr>
+          </a:solidFill>
+          <a:ln>
+            <a:noFill/>
+          </a:ln>
+        </p:spPr>
+        <p:style>
+          <a:lnRef idx="2">
+            <a:schemeClr val="accent1">
+              <a:shade val="15000"/>
+            </a:schemeClr>
+          </a:lnRef>
+          <a:fillRef idx="1">
+            <a:schemeClr val="accent1"/>
+          </a:fillRef>
+          <a:effectRef idx="0">
+            <a:schemeClr val="accent1"/>
+          </a:effectRef>
+          <a:fontRef idx="minor">
+            <a:schemeClr val="lt1"/>
+          </a:fontRef>
+        </p:style>
+        <p:txBody>
+          <a:bodyPr rtlCol="0" anchor="ctr"/>
+          <a:lstStyle/>
+          <a:p>
+            <a:pPr algn="ctr"/>
+            <a:endParaRPr lang="en-US"/>
+          </a:p>
+        </p:txBody>
+      </p:sp>
+      <p:sp>
+        <p:nvSpPr>
+          <p:cNvPr id="44" name="Rectangle 43">
+            <a:extLst>
+              <a:ext uri="{FF2B5EF4-FFF2-40B4-BE49-F238E27FC236}">
+                <a16:creationId xmlns:a16="http://schemas.microsoft.com/office/drawing/2014/main" id="{E0C4C903-D7A4-5BF2-4054-B795EFD04561}"/>
+              </a:ext>
+            </a:extLst>
+          </p:cNvPr>
+          <p:cNvSpPr/>
+          <p:nvPr/>
+        </p:nvSpPr>
+        <p:spPr>
+          <a:xfrm rot="10800000">
+            <a:off x="1835599" y="12772760"/>
+            <a:ext cx="1828800" cy="1828800"/>
+          </a:xfrm>
+          <a:prstGeom prst="rect">
+            <a:avLst/>
+          </a:prstGeom>
+          <a:solidFill>
+            <a:schemeClr val="bg1">
+              <a:lumMod val="65000"/>
+            </a:schemeClr>
+          </a:solidFill>
+          <a:ln>
+            <a:noFill/>
+          </a:ln>
+        </p:spPr>
+        <p:style>
+          <a:lnRef idx="2">
+            <a:schemeClr val="accent1">
+              <a:shade val="15000"/>
+            </a:schemeClr>
+          </a:lnRef>
+          <a:fillRef idx="1">
+            <a:schemeClr val="accent1"/>
+          </a:fillRef>
+          <a:effectRef idx="0">
+            <a:schemeClr val="accent1"/>
+          </a:effectRef>
+          <a:fontRef idx="minor">
+            <a:schemeClr val="lt1"/>
+          </a:fontRef>
+        </p:style>
+        <p:txBody>
+          <a:bodyPr rtlCol="0" anchor="ctr"/>
+          <a:lstStyle/>
+          <a:p>
+            <a:pPr algn="ctr"/>
+            <a:endParaRPr lang="en-US"/>
+          </a:p>
+        </p:txBody>
+      </p:sp>
+      <p:sp>
+        <p:nvSpPr>
+          <p:cNvPr id="45" name="Rectangle 44">
+            <a:extLst>
+              <a:ext uri="{FF2B5EF4-FFF2-40B4-BE49-F238E27FC236}">
+                <a16:creationId xmlns:a16="http://schemas.microsoft.com/office/drawing/2014/main" id="{4E4C54B8-9CBD-8F76-C6CF-CEEDBF131F42}"/>
+              </a:ext>
+            </a:extLst>
+          </p:cNvPr>
+          <p:cNvSpPr/>
+          <p:nvPr/>
+        </p:nvSpPr>
+        <p:spPr>
+          <a:xfrm rot="10800000">
+            <a:off x="1835599" y="16459200"/>
+            <a:ext cx="1828800" cy="1828800"/>
+          </a:xfrm>
+          <a:prstGeom prst="rect">
+            <a:avLst/>
+          </a:prstGeom>
+          <a:solidFill>
+            <a:schemeClr val="bg1">
+              <a:lumMod val="65000"/>
+            </a:schemeClr>
+          </a:solidFill>
+          <a:ln>
+            <a:noFill/>
+          </a:ln>
+        </p:spPr>
+        <p:style>
+          <a:lnRef idx="2">
+            <a:schemeClr val="accent1">
+              <a:shade val="15000"/>
+            </a:schemeClr>
+          </a:lnRef>
+          <a:fillRef idx="1">
+            <a:schemeClr val="accent1"/>
+          </a:fillRef>
+          <a:effectRef idx="0">
+            <a:schemeClr val="accent1"/>
+          </a:effectRef>
+          <a:fontRef idx="minor">
+            <a:schemeClr val="lt1"/>
+          </a:fontRef>
+        </p:style>
+        <p:txBody>
+          <a:bodyPr rtlCol="0" anchor="ctr"/>
+          <a:lstStyle/>
+          <a:p>
+            <a:pPr algn="ctr"/>
+            <a:endParaRPr lang="en-US"/>
+          </a:p>
+        </p:txBody>
+      </p:sp>
+      <p:sp>
+        <p:nvSpPr>
+          <p:cNvPr id="46" name="Rectangle 45">
+            <a:extLst>
+              <a:ext uri="{FF2B5EF4-FFF2-40B4-BE49-F238E27FC236}">
+                <a16:creationId xmlns:a16="http://schemas.microsoft.com/office/drawing/2014/main" id="{2BE43D93-5AFA-F3F2-388E-B1279F6AA8BE}"/>
+              </a:ext>
+            </a:extLst>
+          </p:cNvPr>
+          <p:cNvSpPr/>
+          <p:nvPr/>
+        </p:nvSpPr>
+        <p:spPr>
+          <a:xfrm rot="10800000">
+            <a:off x="12811798" y="12781850"/>
+            <a:ext cx="1828800" cy="1828800"/>
+          </a:xfrm>
+          <a:prstGeom prst="rect">
+            <a:avLst/>
+          </a:prstGeom>
+          <a:solidFill>
+            <a:schemeClr val="bg1">
+              <a:lumMod val="65000"/>
+            </a:schemeClr>
+          </a:solidFill>
+          <a:ln>
+            <a:noFill/>
+          </a:ln>
+        </p:spPr>
+        <p:style>
+          <a:lnRef idx="2">
+            <a:schemeClr val="accent1">
+              <a:shade val="15000"/>
+            </a:schemeClr>
+          </a:lnRef>
+          <a:fillRef idx="1">
+            <a:schemeClr val="accent1"/>
+          </a:fillRef>
+          <a:effectRef idx="0">
+            <a:schemeClr val="accent1"/>
+          </a:effectRef>
+          <a:fontRef idx="minor">
+            <a:schemeClr val="lt1"/>
+          </a:fontRef>
+        </p:style>
+        <p:txBody>
+          <a:bodyPr rtlCol="0" anchor="ctr"/>
+          <a:lstStyle/>
+          <a:p>
+            <a:pPr algn="ctr"/>
+            <a:endParaRPr lang="en-US"/>
+          </a:p>
+        </p:txBody>
+      </p:sp>
+      <p:sp>
+        <p:nvSpPr>
+          <p:cNvPr id="47" name="Rectangle 46">
+            <a:extLst>
+              <a:ext uri="{FF2B5EF4-FFF2-40B4-BE49-F238E27FC236}">
+                <a16:creationId xmlns:a16="http://schemas.microsoft.com/office/drawing/2014/main" id="{8B9DDEB3-0AB2-6417-6D71-79249CDC4D80}"/>
+              </a:ext>
+            </a:extLst>
+          </p:cNvPr>
+          <p:cNvSpPr/>
+          <p:nvPr/>
+        </p:nvSpPr>
+        <p:spPr>
+          <a:xfrm rot="10800000">
+            <a:off x="9164530" y="16459200"/>
+            <a:ext cx="1828800" cy="1828800"/>
+          </a:xfrm>
+          <a:prstGeom prst="rect">
+            <a:avLst/>
+          </a:prstGeom>
+          <a:solidFill>
+            <a:schemeClr val="bg1">
+              <a:lumMod val="65000"/>
+            </a:schemeClr>
+          </a:solidFill>
+          <a:ln>
+            <a:noFill/>
+          </a:ln>
+        </p:spPr>
+        <p:style>
+          <a:lnRef idx="2">
+            <a:schemeClr val="accent1">
+              <a:shade val="15000"/>
+            </a:schemeClr>
+          </a:lnRef>
+          <a:fillRef idx="1">
+            <a:schemeClr val="accent1"/>
+          </a:fillRef>
+          <a:effectRef idx="0">
+            <a:schemeClr val="accent1"/>
+          </a:effectRef>
+          <a:fontRef idx="minor">
+            <a:schemeClr val="lt1"/>
+          </a:fontRef>
+        </p:style>
+        <p:txBody>
+          <a:bodyPr rtlCol="0" anchor="ctr"/>
+          <a:lstStyle/>
+          <a:p>
+            <a:pPr algn="ctr"/>
+            <a:endParaRPr lang="en-US"/>
+          </a:p>
+        </p:txBody>
+      </p:sp>
+      <p:sp>
+        <p:nvSpPr>
+          <p:cNvPr id="48" name="Rectangle 47">
+            <a:extLst>
+              <a:ext uri="{FF2B5EF4-FFF2-40B4-BE49-F238E27FC236}">
+                <a16:creationId xmlns:a16="http://schemas.microsoft.com/office/drawing/2014/main" id="{B63A2A09-0592-8E91-8B48-B76426ECE375}"/>
+              </a:ext>
+            </a:extLst>
+          </p:cNvPr>
+          <p:cNvSpPr/>
+          <p:nvPr/>
+        </p:nvSpPr>
+        <p:spPr>
+          <a:xfrm rot="10800000">
+            <a:off x="3400" y="14601560"/>
+            <a:ext cx="1828800" cy="1828800"/>
+          </a:xfrm>
+          <a:prstGeom prst="rect">
+            <a:avLst/>
+          </a:prstGeom>
+          <a:solidFill>
+            <a:schemeClr val="bg1">
+              <a:lumMod val="65000"/>
+            </a:schemeClr>
+          </a:solidFill>
+          <a:ln>
+            <a:noFill/>
+          </a:ln>
+        </p:spPr>
+        <p:style>
+          <a:lnRef idx="2">
+            <a:schemeClr val="accent1">
+              <a:shade val="15000"/>
+            </a:schemeClr>
+          </a:lnRef>
+          <a:fillRef idx="1">
+            <a:schemeClr val="accent1"/>
+          </a:fillRef>
+          <a:effectRef idx="0">
+            <a:schemeClr val="accent1"/>
+          </a:effectRef>
+          <a:fontRef idx="minor">
+            <a:schemeClr val="lt1"/>
+          </a:fontRef>
+        </p:style>
+        <p:txBody>
+          <a:bodyPr rtlCol="0" anchor="ctr"/>
+          <a:lstStyle/>
+          <a:p>
+            <a:pPr algn="ctr"/>
+            <a:endParaRPr lang="en-US"/>
+          </a:p>
+        </p:txBody>
+      </p:sp>
+      <p:sp>
+        <p:nvSpPr>
+          <p:cNvPr id="49" name="Rectangle 48">
+            <a:extLst>
+              <a:ext uri="{FF2B5EF4-FFF2-40B4-BE49-F238E27FC236}">
+                <a16:creationId xmlns:a16="http://schemas.microsoft.com/office/drawing/2014/main" id="{7385E990-2A37-A42C-7C1A-9E3C1654F54E}"/>
+              </a:ext>
+            </a:extLst>
+          </p:cNvPr>
+          <p:cNvSpPr/>
+          <p:nvPr/>
+        </p:nvSpPr>
+        <p:spPr>
+          <a:xfrm rot="10800000">
+            <a:off x="12815214" y="16430360"/>
+            <a:ext cx="1828800" cy="1828800"/>
+          </a:xfrm>
+          <a:prstGeom prst="rect">
+            <a:avLst/>
+          </a:prstGeom>
+          <a:solidFill>
+            <a:schemeClr val="bg1">
+              <a:lumMod val="65000"/>
+            </a:schemeClr>
+          </a:solidFill>
+          <a:ln>
+            <a:noFill/>
+          </a:ln>
+        </p:spPr>
+        <p:style>
+          <a:lnRef idx="2">
+            <a:schemeClr val="accent1">
+              <a:shade val="15000"/>
+            </a:schemeClr>
+          </a:lnRef>
+          <a:fillRef idx="1">
+            <a:schemeClr val="accent1"/>
+          </a:fillRef>
+          <a:effectRef idx="0">
+            <a:schemeClr val="accent1"/>
+          </a:effectRef>
+          <a:fontRef idx="minor">
+            <a:schemeClr val="lt1"/>
+          </a:fontRef>
+        </p:style>
+        <p:txBody>
+          <a:bodyPr rtlCol="0" anchor="ctr"/>
+          <a:lstStyle/>
+          <a:p>
+            <a:pPr algn="ctr"/>
+            <a:endParaRPr lang="en-US"/>
+          </a:p>
+        </p:txBody>
+      </p:sp>
       <p:grpSp>
         <p:nvGrpSpPr>
           <p:cNvPr id="17" name="Group 16">

</xml_diff>